<commit_message>
Geschichte 11: Übersicht Quelleninterpretation anschaulicher, formale Analyse mit TATTE(A)
Co-Authored-By: Claude Opus 5.5 <noreply@anthropic.com>
Claude-Session: https://claude.ai/code/session_013iN4Tiarea1J9YUJHZ9iqC
</commit_message>
<xml_diff>
--- a/Geschichte_11/Doppelstunde_Test_Quellenanalyse/Folien_Quellenanalyse.pptx
+++ b/Geschichte_11/Doppelstunde_Test_Quellenanalyse/Folien_Quellenanalyse.pptx
@@ -2201,7 +2201,7 @@
           <a:p>
             <a:r>
               <a:rPr lang="en-US" dirty="0"/>
-              <a:t>43–44 Min. Weitere gute Antworten: Textart, Zeit und Ort sowie Adressat fehlen; „Demokratie eingeführt“ steht so nicht in der Quelle.</a:t>
+              <a:t>43–44 Min. Weitere gute Antworten: TATTE(A)-Angaben fehlen (Titel, Textsorte, Entstehung, Adressat); „Demokratie eingeführt“ steht so nicht in der Quelle.</a:t>
             </a:r>
             <a:endParaRPr lang="en-US" dirty="0"/>
           </a:p>
@@ -3945,8 +3945,8 @@
         </p:nvSpPr>
         <p:spPr>
           <a:xfrm>
-            <a:off x="411480" y="1188720"/>
-            <a:ext cx="3017520" cy="566928"/>
+            <a:off x="411480" y="1170432"/>
+            <a:ext cx="3017520" cy="530352"/>
           </a:xfrm>
           <a:prstGeom prst="rect">
             <a:avLst/>
@@ -3970,7 +3970,7 @@
                 <a:ea typeface="Calibri" pitchFamily="34" charset="-122"/>
                 <a:cs typeface="Calibri" pitchFamily="34" charset="-120"/>
               </a:rPr>
-              <a:t>Autor</a:t>
+              <a:t>Titel</a:t>
             </a:r>
             <a:endParaRPr lang="en-US" sz="2700" dirty="0"/>
           </a:p>
@@ -3984,8 +3984,8 @@
         </p:nvSpPr>
         <p:spPr>
           <a:xfrm>
-            <a:off x="3611880" y="1188720"/>
-            <a:ext cx="5120640" cy="566928"/>
+            <a:off x="3611880" y="1170432"/>
+            <a:ext cx="5120640" cy="530352"/>
           </a:xfrm>
           <a:prstGeom prst="rect">
             <a:avLst/>
@@ -4009,7 +4009,7 @@
                 <a:ea typeface="Calibri" pitchFamily="34" charset="-122"/>
                 <a:cs typeface="Calibri" pitchFamily="34" charset="-120"/>
               </a:rPr>
-              <a:t>Solon, Archon und Gesetzgeber Athens</a:t>
+              <a:t>ohne Titel (Fragment)</a:t>
             </a:r>
             <a:endParaRPr lang="en-US" sz="2700" dirty="0"/>
           </a:p>
@@ -4023,8 +4023,8 @@
         </p:nvSpPr>
         <p:spPr>
           <a:xfrm>
-            <a:off x="411480" y="1874520"/>
-            <a:ext cx="3017520" cy="566928"/>
+            <a:off x="411480" y="1773936"/>
+            <a:ext cx="3017520" cy="530352"/>
           </a:xfrm>
           <a:prstGeom prst="rect">
             <a:avLst/>
@@ -4048,7 +4048,7 @@
                 <a:ea typeface="Calibri" pitchFamily="34" charset="-122"/>
                 <a:cs typeface="Calibri" pitchFamily="34" charset="-120"/>
               </a:rPr>
-              <a:t>Zeit und Ort</a:t>
+              <a:t>Autor</a:t>
             </a:r>
             <a:endParaRPr lang="en-US" sz="2700" dirty="0"/>
           </a:p>
@@ -4062,8 +4062,8 @@
         </p:nvSpPr>
         <p:spPr>
           <a:xfrm>
-            <a:off x="3611880" y="1874520"/>
-            <a:ext cx="5120640" cy="566928"/>
+            <a:off x="3611880" y="1773936"/>
+            <a:ext cx="5120640" cy="530352"/>
           </a:xfrm>
           <a:prstGeom prst="rect">
             <a:avLst/>
@@ -4087,7 +4087,7 @@
                 <a:ea typeface="Calibri" pitchFamily="34" charset="-122"/>
                 <a:cs typeface="Calibri" pitchFamily="34" charset="-120"/>
               </a:rPr>
-              <a:t>um 590 v. Chr. in Athen</a:t>
+              <a:t>Solon, Gesetzgeber Athens</a:t>
             </a:r>
             <a:endParaRPr lang="en-US" sz="2700" dirty="0"/>
           </a:p>
@@ -4101,8 +4101,8 @@
         </p:nvSpPr>
         <p:spPr>
           <a:xfrm>
-            <a:off x="411480" y="2560320"/>
-            <a:ext cx="3017520" cy="566928"/>
+            <a:off x="411480" y="2377440"/>
+            <a:ext cx="3017520" cy="530352"/>
           </a:xfrm>
           <a:prstGeom prst="rect">
             <a:avLst/>
@@ -4126,7 +4126,7 @@
                 <a:ea typeface="Calibri" pitchFamily="34" charset="-122"/>
                 <a:cs typeface="Calibri" pitchFamily="34" charset="-120"/>
               </a:rPr>
-              <a:t>Textart</a:t>
+              <a:t>Textsorte</a:t>
             </a:r>
             <a:endParaRPr lang="en-US" sz="2700" dirty="0"/>
           </a:p>
@@ -4140,8 +4140,8 @@
         </p:nvSpPr>
         <p:spPr>
           <a:xfrm>
-            <a:off x="3611880" y="2560320"/>
-            <a:ext cx="5120640" cy="566928"/>
+            <a:off x="3611880" y="2377440"/>
+            <a:ext cx="5120640" cy="530352"/>
           </a:xfrm>
           <a:prstGeom prst="rect">
             <a:avLst/>
@@ -4179,8 +4179,8 @@
         </p:nvSpPr>
         <p:spPr>
           <a:xfrm>
-            <a:off x="411480" y="3246120"/>
-            <a:ext cx="3017520" cy="566928"/>
+            <a:off x="411480" y="2980944"/>
+            <a:ext cx="3017520" cy="530352"/>
           </a:xfrm>
           <a:prstGeom prst="rect">
             <a:avLst/>
@@ -4218,8 +4218,8 @@
         </p:nvSpPr>
         <p:spPr>
           <a:xfrm>
-            <a:off x="3611880" y="3246120"/>
-            <a:ext cx="5120640" cy="566928"/>
+            <a:off x="3611880" y="2980944"/>
+            <a:ext cx="5120640" cy="530352"/>
           </a:xfrm>
           <a:prstGeom prst="rect">
             <a:avLst/>
@@ -4257,8 +4257,8 @@
         </p:nvSpPr>
         <p:spPr>
           <a:xfrm>
-            <a:off x="411480" y="3931920"/>
-            <a:ext cx="3017520" cy="566928"/>
+            <a:off x="411480" y="3584448"/>
+            <a:ext cx="3017520" cy="530352"/>
           </a:xfrm>
           <a:prstGeom prst="rect">
             <a:avLst/>
@@ -4282,6 +4282,84 @@
                 <a:ea typeface="Calibri" pitchFamily="34" charset="-122"/>
                 <a:cs typeface="Calibri" pitchFamily="34" charset="-120"/>
               </a:rPr>
+              <a:t>Entstehung</a:t>
+            </a:r>
+            <a:endParaRPr lang="en-US" sz="2700" dirty="0"/>
+          </a:p>
+        </p:txBody>
+      </p:sp>
+      <p:sp>
+        <p:nvSpPr>
+          <p:cNvPr id="18" name="Text 16"/>
+          <p:cNvSpPr txBox="1"/>
+          <p:nvPr/>
+        </p:nvSpPr>
+        <p:spPr>
+          <a:xfrm>
+            <a:off x="3611880" y="3584448"/>
+            <a:ext cx="5120640" cy="530352"/>
+          </a:xfrm>
+          <a:prstGeom prst="rect">
+            <a:avLst/>
+          </a:prstGeom>
+          <a:noFill/>
+          <a:ln/>
+        </p:spPr>
+        <p:txBody>
+          <a:bodyPr wrap="square" lIns="0" tIns="0" rIns="0" bIns="0" rtlCol="0" anchor="ctr"/>
+          <a:lstStyle/>
+          <a:p>
+            <a:pPr indent="0" marL="0">
+              <a:buNone/>
+            </a:pPr>
+            <a:r>
+              <a:rPr lang="en-US" sz="2700" dirty="0">
+                <a:solidFill>
+                  <a:srgbClr val="2B2318"/>
+                </a:solidFill>
+                <a:latin typeface="Calibri" pitchFamily="34" charset="0"/>
+                <a:ea typeface="Calibri" pitchFamily="34" charset="-122"/>
+                <a:cs typeface="Calibri" pitchFamily="34" charset="-120"/>
+              </a:rPr>
+              <a:t>um 590 v. Chr. in Athen</a:t>
+            </a:r>
+            <a:endParaRPr lang="en-US" sz="2700" dirty="0"/>
+          </a:p>
+        </p:txBody>
+      </p:sp>
+      <p:sp>
+        <p:nvSpPr>
+          <p:cNvPr id="19" name="Text 17"/>
+          <p:cNvSpPr txBox="1"/>
+          <p:nvPr/>
+        </p:nvSpPr>
+        <p:spPr>
+          <a:xfrm>
+            <a:off x="411480" y="4187952"/>
+            <a:ext cx="3017520" cy="530352"/>
+          </a:xfrm>
+          <a:prstGeom prst="rect">
+            <a:avLst/>
+          </a:prstGeom>
+          <a:noFill/>
+          <a:ln/>
+        </p:spPr>
+        <p:txBody>
+          <a:bodyPr wrap="square" lIns="0" tIns="0" rIns="0" bIns="0" rtlCol="0" anchor="ctr"/>
+          <a:lstStyle/>
+          <a:p>
+            <a:pPr indent="0" marL="0">
+              <a:buNone/>
+            </a:pPr>
+            <a:r>
+              <a:rPr lang="en-US" sz="2700" b="1" dirty="0">
+                <a:solidFill>
+                  <a:srgbClr val="AD4426"/>
+                </a:solidFill>
+                <a:latin typeface="Calibri" pitchFamily="34" charset="0"/>
+                <a:ea typeface="Calibri" pitchFamily="34" charset="-122"/>
+                <a:cs typeface="Calibri" pitchFamily="34" charset="-120"/>
+              </a:rPr>
               <a:t>Adressat</a:t>
             </a:r>
             <a:endParaRPr lang="en-US" sz="2700" dirty="0"/>
@@ -4290,14 +4368,14 @@
       </p:sp>
       <p:sp>
         <p:nvSpPr>
-          <p:cNvPr id="18" name="Text 16"/>
-          <p:cNvSpPr txBox="1"/>
-          <p:nvPr/>
-        </p:nvSpPr>
-        <p:spPr>
-          <a:xfrm>
-            <a:off x="3611880" y="3931920"/>
-            <a:ext cx="5120640" cy="566928"/>
+          <p:cNvPr id="20" name="Text 18"/>
+          <p:cNvSpPr txBox="1"/>
+          <p:nvPr/>
+        </p:nvSpPr>
+        <p:spPr>
+          <a:xfrm>
+            <a:off x="3611880" y="4187952"/>
+            <a:ext cx="5120640" cy="530352"/>
           </a:xfrm>
           <a:prstGeom prst="rect">
             <a:avLst/>
@@ -4764,7 +4842,7 @@
                 <a:ea typeface="Calibri" pitchFamily="34" charset="-122"/>
                 <a:cs typeface="Calibri" pitchFamily="34" charset="-120"/>
               </a:rPr>
-              <a:t>„Bei der Quelle handelt es sich um ein Gedicht des athenischen Gesetzgebers Solon, das um 590 v. Chr. in Athen entstand. Er wendet sich an die Athener und rechtfertigt seine Reformen.“</a:t>
+              <a:t>„Bei der Quelle handelt es sich um ein Gedicht ohne Titel des athenischen Gesetzgebers Solon, das um 590 v. Chr. in Athen entstand. Er wendet sich an die Athener und rechtfertigt seine Reformen.“</a:t>
             </a:r>
             <a:endParaRPr lang="en-US" sz="2700" dirty="0"/>
           </a:p>
@@ -5367,7 +5445,7 @@
                 <a:ea typeface="Calibri" pitchFamily="34" charset="-122"/>
                 <a:cs typeface="Calibri" pitchFamily="34" charset="-120"/>
               </a:rPr>
-              <a:t>Fülle die fünf Felder in 2a aus.</a:t>
+              <a:t>Fülle die sechs TATTE(A)-Felder in 2a aus.</a:t>
             </a:r>
             <a:endParaRPr lang="en-US" sz="2700" dirty="0"/>
           </a:p>
@@ -17610,7 +17688,7 @@
                 <a:ea typeface="Cambria" pitchFamily="34" charset="-122"/>
                 <a:cs typeface="Cambria" pitchFamily="34" charset="-120"/>
               </a:rPr>
-              <a:t>2a Formale Aspekte</a:t>
+              <a:t>2a TATTE(A)</a:t>
             </a:r>
             <a:endParaRPr lang="en-US" sz="3600" dirty="0"/>
           </a:p>
@@ -17667,12 +17745,12 @@
         </p:nvSpPr>
         <p:spPr>
           <a:xfrm>
-            <a:off x="411480" y="1188720"/>
-            <a:ext cx="3017520" cy="566928"/>
-          </a:xfrm>
-          <a:prstGeom prst="roundRect">
-            <a:avLst>
-              <a:gd name="adj" fmla="val 12903"/>
+            <a:off x="411480" y="1170432"/>
+            <a:ext cx="3017520" cy="530352"/>
+          </a:xfrm>
+          <a:prstGeom prst="roundRect">
+            <a:avLst>
+              <a:gd name="adj" fmla="val 13793"/>
             </a:avLst>
           </a:prstGeom>
           <a:solidFill>
@@ -17681,10 +17759,10 @@
           <a:ln/>
         </p:spPr>
         <p:txBody>
-          <a:bodyPr wrap="square" lIns="0" tIns="0" rIns="0" bIns="0" rtlCol="0" anchor="ctr"/>
-          <a:lstStyle/>
-          <a:p>
-            <a:pPr algn="ctr" indent="0" marL="0">
+          <a:bodyPr wrap="square" lIns="0" tIns="101600" rIns="0" bIns="0" rtlCol="0" anchor="ctr"/>
+          <a:lstStyle/>
+          <a:p>
+            <a:pPr algn="l" indent="0" marL="0">
               <a:buNone/>
             </a:pPr>
             <a:r>
@@ -17696,7 +17774,7 @@
                 <a:ea typeface="Calibri" pitchFamily="34" charset="-122"/>
                 <a:cs typeface="Calibri" pitchFamily="34" charset="-120"/>
               </a:rPr>
-              <a:t>Autor</a:t>
+              <a:t>T  Titel</a:t>
             </a:r>
             <a:endParaRPr lang="en-US" sz="2700" dirty="0"/>
           </a:p>
@@ -17710,8 +17788,8 @@
         </p:nvSpPr>
         <p:spPr>
           <a:xfrm>
-            <a:off x="3611880" y="1188720"/>
-            <a:ext cx="5120640" cy="566928"/>
+            <a:off x="3611880" y="1170432"/>
+            <a:ext cx="5120640" cy="530352"/>
           </a:xfrm>
           <a:prstGeom prst="rect">
             <a:avLst/>
@@ -17735,7 +17813,7 @@
                 <a:ea typeface="Calibri" pitchFamily="34" charset="-122"/>
                 <a:cs typeface="Calibri" pitchFamily="34" charset="-120"/>
               </a:rPr>
-              <a:t>Wer? Amt, Stellung?</a:t>
+              <a:t>Wie heißt der Text?</a:t>
             </a:r>
             <a:endParaRPr lang="en-US" sz="2700" dirty="0"/>
           </a:p>
@@ -17749,12 +17827,12 @@
         </p:nvSpPr>
         <p:spPr>
           <a:xfrm>
-            <a:off x="411480" y="1874520"/>
-            <a:ext cx="3017520" cy="566928"/>
-          </a:xfrm>
-          <a:prstGeom prst="roundRect">
-            <a:avLst>
-              <a:gd name="adj" fmla="val 12903"/>
+            <a:off x="411480" y="1773936"/>
+            <a:ext cx="3017520" cy="530352"/>
+          </a:xfrm>
+          <a:prstGeom prst="roundRect">
+            <a:avLst>
+              <a:gd name="adj" fmla="val 13793"/>
             </a:avLst>
           </a:prstGeom>
           <a:solidFill>
@@ -17763,10 +17841,10 @@
           <a:ln/>
         </p:spPr>
         <p:txBody>
-          <a:bodyPr wrap="square" lIns="0" tIns="0" rIns="0" bIns="0" rtlCol="0" anchor="ctr"/>
-          <a:lstStyle/>
-          <a:p>
-            <a:pPr algn="ctr" indent="0" marL="0">
+          <a:bodyPr wrap="square" lIns="0" tIns="101600" rIns="0" bIns="0" rtlCol="0" anchor="ctr"/>
+          <a:lstStyle/>
+          <a:p>
+            <a:pPr algn="l" indent="0" marL="0">
               <a:buNone/>
             </a:pPr>
             <a:r>
@@ -17778,7 +17856,7 @@
                 <a:ea typeface="Calibri" pitchFamily="34" charset="-122"/>
                 <a:cs typeface="Calibri" pitchFamily="34" charset="-120"/>
               </a:rPr>
-              <a:t>Zeit und Ort</a:t>
+              <a:t>A  Autor</a:t>
             </a:r>
             <a:endParaRPr lang="en-US" sz="2700" dirty="0"/>
           </a:p>
@@ -17792,8 +17870,8 @@
         </p:nvSpPr>
         <p:spPr>
           <a:xfrm>
-            <a:off x="3611880" y="1874520"/>
-            <a:ext cx="5120640" cy="566928"/>
+            <a:off x="3611880" y="1773936"/>
+            <a:ext cx="5120640" cy="530352"/>
           </a:xfrm>
           <a:prstGeom prst="rect">
             <a:avLst/>
@@ -17817,7 +17895,7 @@
                 <a:ea typeface="Calibri" pitchFamily="34" charset="-122"/>
                 <a:cs typeface="Calibri" pitchFamily="34" charset="-120"/>
               </a:rPr>
-              <a:t>Wann und wo entstanden?</a:t>
+              <a:t>Wer? Amt, Stellung?</a:t>
             </a:r>
             <a:endParaRPr lang="en-US" sz="2700" dirty="0"/>
           </a:p>
@@ -17831,12 +17909,12 @@
         </p:nvSpPr>
         <p:spPr>
           <a:xfrm>
-            <a:off x="411480" y="2560320"/>
-            <a:ext cx="3017520" cy="566928"/>
-          </a:xfrm>
-          <a:prstGeom prst="roundRect">
-            <a:avLst>
-              <a:gd name="adj" fmla="val 12903"/>
+            <a:off x="411480" y="2377440"/>
+            <a:ext cx="3017520" cy="530352"/>
+          </a:xfrm>
+          <a:prstGeom prst="roundRect">
+            <a:avLst>
+              <a:gd name="adj" fmla="val 13793"/>
             </a:avLst>
           </a:prstGeom>
           <a:solidFill>
@@ -17845,10 +17923,10 @@
           <a:ln/>
         </p:spPr>
         <p:txBody>
-          <a:bodyPr wrap="square" lIns="0" tIns="0" rIns="0" bIns="0" rtlCol="0" anchor="ctr"/>
-          <a:lstStyle/>
-          <a:p>
-            <a:pPr algn="ctr" indent="0" marL="0">
+          <a:bodyPr wrap="square" lIns="0" tIns="101600" rIns="0" bIns="0" rtlCol="0" anchor="ctr"/>
+          <a:lstStyle/>
+          <a:p>
+            <a:pPr algn="l" indent="0" marL="0">
               <a:buNone/>
             </a:pPr>
             <a:r>
@@ -17860,7 +17938,7 @@
                 <a:ea typeface="Calibri" pitchFamily="34" charset="-122"/>
                 <a:cs typeface="Calibri" pitchFamily="34" charset="-120"/>
               </a:rPr>
-              <a:t>Textart</a:t>
+              <a:t>T  Textsorte</a:t>
             </a:r>
             <a:endParaRPr lang="en-US" sz="2700" dirty="0"/>
           </a:p>
@@ -17874,8 +17952,8 @@
         </p:nvSpPr>
         <p:spPr>
           <a:xfrm>
-            <a:off x="3611880" y="2560320"/>
-            <a:ext cx="5120640" cy="566928"/>
+            <a:off x="3611880" y="2377440"/>
+            <a:ext cx="5120640" cy="530352"/>
           </a:xfrm>
           <a:prstGeom prst="rect">
             <a:avLst/>
@@ -17913,12 +17991,12 @@
         </p:nvSpPr>
         <p:spPr>
           <a:xfrm>
-            <a:off x="411480" y="3246120"/>
-            <a:ext cx="3017520" cy="566928"/>
-          </a:xfrm>
-          <a:prstGeom prst="roundRect">
-            <a:avLst>
-              <a:gd name="adj" fmla="val 12903"/>
+            <a:off x="411480" y="2980944"/>
+            <a:ext cx="3017520" cy="530352"/>
+          </a:xfrm>
+          <a:prstGeom prst="roundRect">
+            <a:avLst>
+              <a:gd name="adj" fmla="val 13793"/>
             </a:avLst>
           </a:prstGeom>
           <a:solidFill>
@@ -17927,10 +18005,10 @@
           <a:ln/>
         </p:spPr>
         <p:txBody>
-          <a:bodyPr wrap="square" lIns="0" tIns="0" rIns="0" bIns="0" rtlCol="0" anchor="ctr"/>
-          <a:lstStyle/>
-          <a:p>
-            <a:pPr algn="ctr" indent="0" marL="0">
+          <a:bodyPr wrap="square" lIns="0" tIns="101600" rIns="0" bIns="0" rtlCol="0" anchor="ctr"/>
+          <a:lstStyle/>
+          <a:p>
+            <a:pPr algn="l" indent="0" marL="0">
               <a:buNone/>
             </a:pPr>
             <a:r>
@@ -17942,7 +18020,7 @@
                 <a:ea typeface="Calibri" pitchFamily="34" charset="-122"/>
                 <a:cs typeface="Calibri" pitchFamily="34" charset="-120"/>
               </a:rPr>
-              <a:t>Thema</a:t>
+              <a:t>T  Thema</a:t>
             </a:r>
             <a:endParaRPr lang="en-US" sz="2700" dirty="0"/>
           </a:p>
@@ -17956,8 +18034,8 @@
         </p:nvSpPr>
         <p:spPr>
           <a:xfrm>
-            <a:off x="3611880" y="3246120"/>
-            <a:ext cx="5120640" cy="566928"/>
+            <a:off x="3611880" y="2980944"/>
+            <a:ext cx="5120640" cy="530352"/>
           </a:xfrm>
           <a:prstGeom prst="rect">
             <a:avLst/>
@@ -17995,12 +18073,12 @@
         </p:nvSpPr>
         <p:spPr>
           <a:xfrm>
-            <a:off x="411480" y="3931920"/>
-            <a:ext cx="3017520" cy="566928"/>
-          </a:xfrm>
-          <a:prstGeom prst="roundRect">
-            <a:avLst>
-              <a:gd name="adj" fmla="val 12903"/>
+            <a:off x="411480" y="3584448"/>
+            <a:ext cx="3017520" cy="530352"/>
+          </a:xfrm>
+          <a:prstGeom prst="roundRect">
+            <a:avLst>
+              <a:gd name="adj" fmla="val 13793"/>
             </a:avLst>
           </a:prstGeom>
           <a:solidFill>
@@ -18009,10 +18087,10 @@
           <a:ln/>
         </p:spPr>
         <p:txBody>
-          <a:bodyPr wrap="square" lIns="0" tIns="0" rIns="0" bIns="0" rtlCol="0" anchor="ctr"/>
-          <a:lstStyle/>
-          <a:p>
-            <a:pPr algn="ctr" indent="0" marL="0">
+          <a:bodyPr wrap="square" lIns="0" tIns="101600" rIns="0" bIns="0" rtlCol="0" anchor="ctr"/>
+          <a:lstStyle/>
+          <a:p>
+            <a:pPr algn="l" indent="0" marL="0">
               <a:buNone/>
             </a:pPr>
             <a:r>
@@ -18024,7 +18102,7 @@
                 <a:ea typeface="Calibri" pitchFamily="34" charset="-122"/>
                 <a:cs typeface="Calibri" pitchFamily="34" charset="-120"/>
               </a:rPr>
-              <a:t>Adressat</a:t>
+              <a:t>E  Entstehung</a:t>
             </a:r>
             <a:endParaRPr lang="en-US" sz="2700" dirty="0"/>
           </a:p>
@@ -18038,8 +18116,90 @@
         </p:nvSpPr>
         <p:spPr>
           <a:xfrm>
-            <a:off x="3611880" y="3931920"/>
-            <a:ext cx="5120640" cy="566928"/>
+            <a:off x="3611880" y="3584448"/>
+            <a:ext cx="5120640" cy="530352"/>
+          </a:xfrm>
+          <a:prstGeom prst="rect">
+            <a:avLst/>
+          </a:prstGeom>
+          <a:noFill/>
+          <a:ln/>
+        </p:spPr>
+        <p:txBody>
+          <a:bodyPr wrap="square" lIns="0" tIns="0" rIns="0" bIns="0" rtlCol="0" anchor="ctr"/>
+          <a:lstStyle/>
+          <a:p>
+            <a:pPr indent="0" marL="0">
+              <a:buNone/>
+            </a:pPr>
+            <a:r>
+              <a:rPr lang="en-US" sz="2700" dirty="0">
+                <a:solidFill>
+                  <a:srgbClr val="2B2318"/>
+                </a:solidFill>
+                <a:latin typeface="Calibri" pitchFamily="34" charset="0"/>
+                <a:ea typeface="Calibri" pitchFamily="34" charset="-122"/>
+                <a:cs typeface="Calibri" pitchFamily="34" charset="-120"/>
+              </a:rPr>
+              <a:t>Wann und wo?</a:t>
+            </a:r>
+            <a:endParaRPr lang="en-US" sz="2700" dirty="0"/>
+          </a:p>
+        </p:txBody>
+      </p:sp>
+      <p:sp>
+        <p:nvSpPr>
+          <p:cNvPr id="19" name="Text 17"/>
+          <p:cNvSpPr txBox="1"/>
+          <p:nvPr/>
+        </p:nvSpPr>
+        <p:spPr>
+          <a:xfrm>
+            <a:off x="411480" y="4187952"/>
+            <a:ext cx="3017520" cy="530352"/>
+          </a:xfrm>
+          <a:prstGeom prst="roundRect">
+            <a:avLst>
+              <a:gd name="adj" fmla="val 13793"/>
+            </a:avLst>
+          </a:prstGeom>
+          <a:solidFill>
+            <a:srgbClr val="AD4426"/>
+          </a:solidFill>
+          <a:ln/>
+        </p:spPr>
+        <p:txBody>
+          <a:bodyPr wrap="square" lIns="0" tIns="101600" rIns="0" bIns="0" rtlCol="0" anchor="ctr"/>
+          <a:lstStyle/>
+          <a:p>
+            <a:pPr algn="l" indent="0" marL="0">
+              <a:buNone/>
+            </a:pPr>
+            <a:r>
+              <a:rPr lang="en-US" sz="2700" b="1" dirty="0">
+                <a:solidFill>
+                  <a:srgbClr val="FFFFFF"/>
+                </a:solidFill>
+                <a:latin typeface="Calibri" pitchFamily="34" charset="0"/>
+                <a:ea typeface="Calibri" pitchFamily="34" charset="-122"/>
+                <a:cs typeface="Calibri" pitchFamily="34" charset="-120"/>
+              </a:rPr>
+              <a:t>(A) Adressat</a:t>
+            </a:r>
+            <a:endParaRPr lang="en-US" sz="2700" dirty="0"/>
+          </a:p>
+        </p:txBody>
+      </p:sp>
+      <p:sp>
+        <p:nvSpPr>
+          <p:cNvPr id="20" name="Text 18"/>
+          <p:cNvSpPr txBox="1"/>
+          <p:nvPr/>
+        </p:nvSpPr>
+        <p:spPr>
+          <a:xfrm>
+            <a:off x="3611880" y="4187952"/>
+            <a:ext cx="5120640" cy="530352"/>
           </a:xfrm>
           <a:prstGeom prst="rect">
             <a:avLst/>

</xml_diff>

<commit_message>
Geschichte 11: TATTEA ohne Klammer, Übersicht mit größerer Schrift
Co-Authored-By: Claude Opus 5.5 <noreply@anthropic.com>
Claude-Session: https://claude.ai/code/session_013iN4Tiarea1J9YUJHZ9iqC
</commit_message>
<xml_diff>
--- a/Geschichte_11/Doppelstunde_Test_Quellenanalyse/Folien_Quellenanalyse.pptx
+++ b/Geschichte_11/Doppelstunde_Test_Quellenanalyse/Folien_Quellenanalyse.pptx
@@ -2201,7 +2201,7 @@
           <a:p>
             <a:r>
               <a:rPr lang="en-US" dirty="0"/>
-              <a:t>43–44 Min. Weitere gute Antworten: TATTE(A)-Angaben fehlen (Titel, Textsorte, Entstehung, Adressat); „Demokratie eingeführt“ steht so nicht in der Quelle.</a:t>
+              <a:t>43–44 Min. Weitere gute Antworten: TATTEA-Angaben fehlen (Titel, Textsorte, Entstehung, Adressat); „Demokratie eingeführt“ steht so nicht in der Quelle.</a:t>
             </a:r>
             <a:endParaRPr lang="en-US" dirty="0"/>
           </a:p>
@@ -5445,7 +5445,7 @@
                 <a:ea typeface="Calibri" pitchFamily="34" charset="-122"/>
                 <a:cs typeface="Calibri" pitchFamily="34" charset="-120"/>
               </a:rPr>
-              <a:t>Fülle die sechs TATTE(A)-Felder in 2a aus.</a:t>
+              <a:t>Fülle die sechs TATTEA-Felder in 2a aus.</a:t>
             </a:r>
             <a:endParaRPr lang="en-US" sz="2700" dirty="0"/>
           </a:p>
@@ -17688,7 +17688,7 @@
                 <a:ea typeface="Cambria" pitchFamily="34" charset="-122"/>
                 <a:cs typeface="Cambria" pitchFamily="34" charset="-120"/>
               </a:rPr>
-              <a:t>2a TATTE(A)</a:t>
+              <a:t>2a TATTEA</a:t>
             </a:r>
             <a:endParaRPr lang="en-US" sz="3600" dirty="0"/>
           </a:p>
@@ -18184,7 +18184,7 @@
                 <a:ea typeface="Calibri" pitchFamily="34" charset="-122"/>
                 <a:cs typeface="Calibri" pitchFamily="34" charset="-120"/>
               </a:rPr>
-              <a:t>(A) Adressat</a:t>
+              <a:t>A  Adressat</a:t>
             </a:r>
             <a:endParaRPr lang="en-US" sz="2700" dirty="0"/>
           </a:p>

</xml_diff>